<commit_message>
remove emojis and unicode symbols from all files
</commit_message>
<xml_diff>
--- a/presentation/Blackhat_Presentation.pptx
+++ b/presentation/Blackhat_Presentation.pptx
@@ -4576,7 +4576,7 @@
               </a:defRPr>
             </a:pPr>
             <a:r>
-              <a:t>  → Used stratified splitting and F1-score evaluation</a:t>
+              <a:t>  -&gt; Used stratified splitting and F1-score evaluation</a:t>
             </a:r>
           </a:p>
           <a:p>
@@ -4621,7 +4621,7 @@
               </a:defRPr>
             </a:pPr>
             <a:r>
-              <a:t>  → Leveraged pre-selected IG-SBS features; analysed correlations</a:t>
+              <a:t>  -&gt; Leveraged pre-selected IG-SBS features; analysed correlations</a:t>
             </a:r>
           </a:p>
           <a:p>
@@ -4666,7 +4666,7 @@
               </a:defRPr>
             </a:pPr>
             <a:r>
-              <a:t>  → Fixed random seeds, centralised config, persisted all artefacts</a:t>
+              <a:t>  -&gt; Fixed random seeds, centralised config, persisted all artefacts</a:t>
             </a:r>
           </a:p>
           <a:p>
@@ -4711,7 +4711,7 @@
               </a:defRPr>
             </a:pPr>
             <a:r>
-              <a:t>  → Scaler fitted on training set only; strict split boundaries</a:t>
+              <a:t>  -&gt; Scaler fitted on training set only; strict split boundaries</a:t>
             </a:r>
           </a:p>
         </p:txBody>
@@ -5860,7 +5860,7 @@
               </a:defRPr>
             </a:pPr>
             <a:r>
-              <a:t>  ✗ High false-positive rates on JS-heavy pages</a:t>
+              <a:t>  - High false-positive rates on JS-heavy pages</a:t>
             </a:r>
           </a:p>
           <a:p>
@@ -5876,7 +5876,7 @@
               </a:defRPr>
             </a:pPr>
             <a:r>
-              <a:t>  ✗ Cannot detect obfuscated or zero-day payloads</a:t>
+              <a:t>  - Cannot detect obfuscated or zero-day payloads</a:t>
             </a:r>
           </a:p>
           <a:p>
@@ -5892,7 +5892,7 @@
               </a:defRPr>
             </a:pPr>
             <a:r>
-              <a:t>  ✗ Require continuous manual signature updates</a:t>
+              <a:t>  - Require continuous manual signature updates</a:t>
             </a:r>
           </a:p>
           <a:p>
@@ -5937,7 +5937,7 @@
               </a:defRPr>
             </a:pPr>
             <a:r>
-              <a:t>  ✓ Learns complex, non-linear decision boundaries</a:t>
+              <a:t>  + Learns complex, non-linear decision boundaries</a:t>
             </a:r>
           </a:p>
           <a:p>
@@ -5953,7 +5953,7 @@
               </a:defRPr>
             </a:pPr>
             <a:r>
-              <a:t>  ✓ Detects novel attack variants without explicit rules</a:t>
+              <a:t>  + Detects novel attack variants without explicit rules</a:t>
             </a:r>
           </a:p>
           <a:p>
@@ -5969,7 +5969,7 @@
               </a:defRPr>
             </a:pPr>
             <a:r>
-              <a:t>  ✓ Adapts to evolving attack patterns with retraining</a:t>
+              <a:t>  + Adapts to evolving attack patterns with retraining</a:t>
             </a:r>
           </a:p>
           <a:p>
@@ -5985,7 +5985,7 @@
               </a:defRPr>
             </a:pPr>
             <a:r>
-              <a:t>  ✓ Provides probability scores for risk assessment</a:t>
+              <a:t>  + Provides probability scores for risk assessment</a:t>
             </a:r>
           </a:p>
         </p:txBody>
@@ -6086,7 +6086,7 @@
               </a:defRPr>
             </a:pPr>
             <a:r>
-              <a:t>Likarish et al. (2009) — SVM/NB on HTTP parameters → 92% acc.</a:t>
+              <a:t>Likarish et al. (2009) — SVM/NB on HTTP parameters -&gt; 92% acc.</a:t>
             </a:r>
           </a:p>
           <a:p>
@@ -6102,7 +6102,7 @@
               </a:defRPr>
             </a:pPr>
             <a:r>
-              <a:t>Wang et al. (2018) — CNN on character sequences → 99.2% acc.</a:t>
+              <a:t>Wang et al. (2018) — CNN on character sequences -&gt; 99.2% acc.</a:t>
             </a:r>
           </a:p>
           <a:p>
@@ -6118,7 +6118,7 @@
               </a:defRPr>
             </a:pPr>
             <a:r>
-              <a:t>Mokbal et al. (2019) — MLP with 42 dynamic features → 99.0% acc.</a:t>
+              <a:t>Mokbal et al. (2019) — MLP with 42 dynamic features -&gt; 99.0% acc.</a:t>
             </a:r>
           </a:p>
           <a:p>
@@ -6134,7 +6134,7 @@
               </a:defRPr>
             </a:pPr>
             <a:r>
-              <a:t>Mokbal et al. (2021) — XGBoost + IG-SBS feature selection → 99.4% acc.</a:t>
+              <a:t>Mokbal et al. (2021) — XGBoost + IG-SBS feature selection -&gt; 99.4% acc.</a:t>
             </a:r>
           </a:p>
           <a:p>
@@ -6150,7 +6150,7 @@
               </a:defRPr>
             </a:pPr>
             <a:r>
-              <a:t>Fang et al. (2018) — LSTM for sequential XSS patterns → 98.2% acc.</a:t>
+              <a:t>Fang et al. (2018) — LSTM for sequential XSS patterns -&gt; 98.2% acc.</a:t>
             </a:r>
           </a:p>
           <a:p>
@@ -6166,7 +6166,7 @@
               </a:defRPr>
             </a:pPr>
             <a:r>
-              <a:t>Zhou &amp; Wang (2019) — RF ensemble with HTML/JS/URL → 98.8% acc.</a:t>
+              <a:t>Zhou &amp; Wang (2019) — RF ensemble with HTML/JS/URL -&gt; 98.8% acc.</a:t>
             </a:r>
           </a:p>
           <a:p>
@@ -6610,7 +6610,7 @@
               </a:defRPr>
             </a:pPr>
             <a:r>
-              <a:t>  Raw CSV  →  Preprocessing  →  Feature Scaling</a:t>
+              <a:t>  Raw CSV  -&gt;  Preprocessing  -&gt;  Feature Scaling</a:t>
             </a:r>
           </a:p>
           <a:p>
@@ -6642,7 +6642,7 @@
               </a:defRPr>
             </a:pPr>
             <a:r>
-              <a:t>  Evaluation  ←  Training (CV)  ←  Train/Val/Test Split</a:t>
+              <a:t>  Evaluation  &lt;-  Training (CV)  &lt;-  Train/Val/Test Split</a:t>
             </a:r>
           </a:p>
           <a:p>

</xml_diff>